<commit_message>
update request examples for first file
</commit_message>
<xml_diff>
--- a/data/EVRAZ_Agent_improved.pptx
+++ b/data/EVRAZ_Agent_improved.pptx
@@ -3022,7 +3022,7 @@
           </a:prstGeom>
           <a:extLst>
             <a:ext uri="{C572A759-6A51-4108-AA02-DFA0A04FC94B}">
-              <ma14:wrappingTextBoxFlag xmlns="" xmlns:ma14="http://schemas.microsoft.com/office/mac/drawingml/2011/main" val="0"/>
+              <ma14:wrappingTextBoxFlag xmlns:ma14="http://schemas.microsoft.com/office/mac/drawingml/2011/main" xmlns="" val="0"/>
             </a:ext>
           </a:extLst>
         </p:spPr>
@@ -3097,7 +3097,7 @@
           </a:prstGeom>
           <a:extLst>
             <a:ext uri="{C572A759-6A51-4108-AA02-DFA0A04FC94B}">
-              <ma14:wrappingTextBoxFlag xmlns="" xmlns:ma14="http://schemas.microsoft.com/office/mac/drawingml/2011/main" val="0"/>
+              <ma14:wrappingTextBoxFlag xmlns:ma14="http://schemas.microsoft.com/office/mac/drawingml/2011/main" xmlns="" val="0"/>
             </a:ext>
           </a:extLst>
         </p:spPr>
@@ -5227,7 +5227,7 @@
           </a:prstGeom>
           <a:extLst>
             <a:ext uri="{C572A759-6A51-4108-AA02-DFA0A04FC94B}">
-              <ma14:wrappingTextBoxFlag xmlns="" xmlns:ma14="http://schemas.microsoft.com/office/mac/drawingml/2011/main" val="0"/>
+              <ma14:wrappingTextBoxFlag xmlns:ma14="http://schemas.microsoft.com/office/mac/drawingml/2011/main" xmlns="" val="0"/>
             </a:ext>
           </a:extLst>
         </p:spPr>
@@ -6769,7 +6769,7 @@
           </a:prstGeom>
           <a:extLst>
             <a:ext uri="{C572A759-6A51-4108-AA02-DFA0A04FC94B}">
-              <ma14:wrappingTextBoxFlag xmlns="" xmlns:ma14="http://schemas.microsoft.com/office/mac/drawingml/2011/main" val="0"/>
+              <ma14:wrappingTextBoxFlag xmlns:ma14="http://schemas.microsoft.com/office/mac/drawingml/2011/main" xmlns="" val="0"/>
             </a:ext>
           </a:extLst>
         </p:spPr>
@@ -8554,7 +8554,7 @@
           </a:prstGeom>
           <a:extLst>
             <a:ext uri="{C572A759-6A51-4108-AA02-DFA0A04FC94B}">
-              <ma14:wrappingTextBoxFlag xmlns="" xmlns:ma14="http://schemas.microsoft.com/office/mac/drawingml/2011/main" val="0"/>
+              <ma14:wrappingTextBoxFlag xmlns:ma14="http://schemas.microsoft.com/office/mac/drawingml/2011/main" xmlns="" val="0"/>
             </a:ext>
           </a:extLst>
         </p:spPr>
@@ -9937,7 +9937,7 @@
           </a:prstGeom>
           <a:extLst>
             <a:ext uri="{C572A759-6A51-4108-AA02-DFA0A04FC94B}">
-              <ma14:wrappingTextBoxFlag xmlns="" xmlns:ma14="http://schemas.microsoft.com/office/mac/drawingml/2011/main" val="0"/>
+              <ma14:wrappingTextBoxFlag xmlns:ma14="http://schemas.microsoft.com/office/mac/drawingml/2011/main" xmlns="" val="0"/>
             </a:ext>
           </a:extLst>
         </p:spPr>
@@ -11417,7 +11417,7 @@
           </a:prstGeom>
           <a:extLst>
             <a:ext uri="{C572A759-6A51-4108-AA02-DFA0A04FC94B}">
-              <ma14:wrappingTextBoxFlag xmlns="" xmlns:ma14="http://schemas.microsoft.com/office/mac/drawingml/2011/main" val="0"/>
+              <ma14:wrappingTextBoxFlag xmlns:ma14="http://schemas.microsoft.com/office/mac/drawingml/2011/main" xmlns="" val="0"/>
             </a:ext>
           </a:extLst>
         </p:spPr>
@@ -13190,7 +13190,7 @@
           </a:prstGeom>
           <a:extLst>
             <a:ext uri="{C572A759-6A51-4108-AA02-DFA0A04FC94B}">
-              <ma14:wrappingTextBoxFlag xmlns="" xmlns:ma14="http://schemas.microsoft.com/office/mac/drawingml/2011/main" val="0"/>
+              <ma14:wrappingTextBoxFlag xmlns:ma14="http://schemas.microsoft.com/office/mac/drawingml/2011/main" xmlns="" val="0"/>
             </a:ext>
           </a:extLst>
         </p:spPr>
@@ -13329,35 +13329,35 @@
           <p:nvPr>
             <p:extLst>
               <p:ext uri="{D42A27DB-BD31-4B8C-83A1-F6EECF244321}">
-                <p14:modId xmlns:p14="http://schemas.microsoft.com/office/powerpoint/2010/main" val="1579011935"/>
+                <p14:modId xmlns:p14="http://schemas.microsoft.com/office/powerpoint/2010/main" val="1473532423"/>
               </p:ext>
             </p:extLst>
           </p:nvPr>
         </p:nvGraphicFramePr>
         <p:xfrm>
-          <a:off x="548640" y="1463040"/>
-          <a:ext cx="11064240" cy="2595880"/>
+          <a:off x="548640" y="1463039"/>
+          <a:ext cx="11109960" cy="4499223"/>
         </p:xfrm>
         <a:graphic>
           <a:graphicData uri="http://schemas.openxmlformats.org/drawingml/2006/table">
             <a:tbl>
               <a:tblPr/>
               <a:tblGrid>
-                <a:gridCol w="1737360">
+                <a:gridCol w="1744539">
                   <a:extLst>
                     <a:ext uri="{9D8B030D-6E8A-4147-A177-3AD203B41FA5}">
                       <a16:colId xmlns:a16="http://schemas.microsoft.com/office/drawing/2014/main" val="20000"/>
                     </a:ext>
                   </a:extLst>
                 </a:gridCol>
-                <a:gridCol w="5120640">
+                <a:gridCol w="5141800">
                   <a:extLst>
                     <a:ext uri="{9D8B030D-6E8A-4147-A177-3AD203B41FA5}">
                       <a16:colId xmlns:a16="http://schemas.microsoft.com/office/drawing/2014/main" val="20001"/>
                     </a:ext>
                   </a:extLst>
                 </a:gridCol>
-                <a:gridCol w="4206240">
+                <a:gridCol w="4223621">
                   <a:extLst>
                     <a:ext uri="{9D8B030D-6E8A-4147-A177-3AD203B41FA5}">
                       <a16:colId xmlns:a16="http://schemas.microsoft.com/office/drawing/2014/main" val="20002"/>
@@ -13365,7 +13365,7 @@
                   </a:extLst>
                 </a:gridCol>
               </a:tblGrid>
-              <a:tr h="0">
+              <a:tr h="519480">
                 <a:tc>
                   <a:txBody>
                     <a:bodyPr/>
@@ -13555,7 +13555,7 @@
                   </a:ext>
                 </a:extLst>
               </a:tr>
-              <a:tr h="0">
+              <a:tr h="862863">
                 <a:tc>
                   <a:txBody>
                     <a:bodyPr/>
@@ -13745,7 +13745,7 @@
                   </a:ext>
                 </a:extLst>
               </a:tr>
-              <a:tr h="0">
+              <a:tr h="519480">
                 <a:tc>
                   <a:txBody>
                     <a:bodyPr/>
@@ -13935,7 +13935,7 @@
                   </a:ext>
                 </a:extLst>
               </a:tr>
-              <a:tr h="0">
+              <a:tr h="519480">
                 <a:tc>
                   <a:txBody>
                     <a:bodyPr/>
@@ -14125,7 +14125,7 @@
                   </a:ext>
                 </a:extLst>
               </a:tr>
-              <a:tr h="0">
+              <a:tr h="519480">
                 <a:tc>
                   <a:txBody>
                     <a:bodyPr/>
@@ -14315,7 +14315,7 @@
                   </a:ext>
                 </a:extLst>
               </a:tr>
-              <a:tr h="0">
+              <a:tr h="519480">
                 <a:tc>
                   <a:txBody>
                     <a:bodyPr/>
@@ -14505,7 +14505,7 @@
                   </a:ext>
                 </a:extLst>
               </a:tr>
-              <a:tr h="0">
+              <a:tr h="519480">
                 <a:tc>
                   <a:txBody>
                     <a:bodyPr/>
@@ -14695,7 +14695,7 @@
                   </a:ext>
                 </a:extLst>
               </a:tr>
-              <a:tr h="0">
+              <a:tr h="519480">
                 <a:tc>
                   <a:txBody>
                     <a:bodyPr/>
@@ -14909,7 +14909,7 @@
           </a:prstGeom>
           <a:extLst>
             <a:ext uri="{C572A759-6A51-4108-AA02-DFA0A04FC94B}">
-              <ma14:wrappingTextBoxFlag xmlns="" xmlns:ma14="http://schemas.microsoft.com/office/mac/drawingml/2011/main" val="0"/>
+              <ma14:wrappingTextBoxFlag xmlns:ma14="http://schemas.microsoft.com/office/mac/drawingml/2011/main" xmlns="" val="0"/>
             </a:ext>
           </a:extLst>
         </p:spPr>
@@ -16410,7 +16410,7 @@
           </a:prstGeom>
           <a:extLst>
             <a:ext uri="{C572A759-6A51-4108-AA02-DFA0A04FC94B}">
-              <ma14:wrappingTextBoxFlag xmlns="" xmlns:ma14="http://schemas.microsoft.com/office/mac/drawingml/2011/main" val="0"/>
+              <ma14:wrappingTextBoxFlag xmlns:ma14="http://schemas.microsoft.com/office/mac/drawingml/2011/main" xmlns="" val="0"/>
             </a:ext>
           </a:extLst>
         </p:spPr>
@@ -17289,7 +17289,7 @@
           </a:prstGeom>
           <a:extLst>
             <a:ext uri="{C572A759-6A51-4108-AA02-DFA0A04FC94B}">
-              <ma14:wrappingTextBoxFlag xmlns="" xmlns:ma14="http://schemas.microsoft.com/office/mac/drawingml/2011/main" val="0"/>
+              <ma14:wrappingTextBoxFlag xmlns:ma14="http://schemas.microsoft.com/office/mac/drawingml/2011/main" xmlns="" val="0"/>
             </a:ext>
           </a:extLst>
         </p:spPr>
@@ -18055,7 +18055,7 @@
           </a:prstGeom>
           <a:extLst>
             <a:ext uri="{C572A759-6A51-4108-AA02-DFA0A04FC94B}">
-              <ma14:wrappingTextBoxFlag xmlns="" xmlns:ma14="http://schemas.microsoft.com/office/mac/drawingml/2011/main" val="0"/>
+              <ma14:wrappingTextBoxFlag xmlns:ma14="http://schemas.microsoft.com/office/mac/drawingml/2011/main" xmlns="" val="0"/>
             </a:ext>
           </a:extLst>
         </p:spPr>
@@ -19223,7 +19223,7 @@
                   <a:schemeClr val="bg2"/>
                 </a:solidFill>
               </a:rPr>
-              <a:t>Тесты · CI/CD</a:t>
+              <a:t>Тесты · CI</a:t>
             </a:r>
             <a:endParaRPr lang="en-US" sz="1300" dirty="0"/>
           </a:p>
@@ -19597,7 +19597,7 @@
           </a:prstGeom>
           <a:extLst>
             <a:ext uri="{C572A759-6A51-4108-AA02-DFA0A04FC94B}">
-              <ma14:wrappingTextBoxFlag xmlns="" xmlns:ma14="http://schemas.microsoft.com/office/mac/drawingml/2011/main" val="0"/>
+              <ma14:wrappingTextBoxFlag xmlns:ma14="http://schemas.microsoft.com/office/mac/drawingml/2011/main" xmlns="" val="0"/>
             </a:ext>
           </a:extLst>
         </p:spPr>
@@ -19736,14 +19736,14 @@
           <p:nvPr>
             <p:extLst>
               <p:ext uri="{D42A27DB-BD31-4B8C-83A1-F6EECF244321}">
-                <p14:modId xmlns:p14="http://schemas.microsoft.com/office/powerpoint/2010/main" val="1579011935"/>
+                <p14:modId xmlns:p14="http://schemas.microsoft.com/office/powerpoint/2010/main" val="2638435565"/>
               </p:ext>
             </p:extLst>
           </p:nvPr>
         </p:nvGraphicFramePr>
         <p:xfrm>
-          <a:off x="548640" y="1463040"/>
-          <a:ext cx="11064240" cy="914400"/>
+          <a:off x="548640" y="1463039"/>
+          <a:ext cx="11064240" cy="2726406"/>
         </p:xfrm>
         <a:graphic>
           <a:graphicData uri="http://schemas.openxmlformats.org/drawingml/2006/table">
@@ -19765,7 +19765,7 @@
                   </a:extLst>
                 </a:gridCol>
               </a:tblGrid>
-              <a:tr h="0">
+              <a:tr h="454401">
                 <a:tc>
                   <a:txBody>
                     <a:bodyPr/>
@@ -19894,7 +19894,7 @@
                   </a:ext>
                 </a:extLst>
               </a:tr>
-              <a:tr h="0">
+              <a:tr h="454401">
                 <a:tc>
                   <a:txBody>
                     <a:bodyPr/>
@@ -20023,7 +20023,7 @@
                   </a:ext>
                 </a:extLst>
               </a:tr>
-              <a:tr h="0">
+              <a:tr h="454401">
                 <a:tc>
                   <a:txBody>
                     <a:bodyPr/>
@@ -20152,7 +20152,7 @@
                   </a:ext>
                 </a:extLst>
               </a:tr>
-              <a:tr h="0">
+              <a:tr h="454401">
                 <a:tc>
                   <a:txBody>
                     <a:bodyPr/>
@@ -20281,7 +20281,7 @@
                   </a:ext>
                 </a:extLst>
               </a:tr>
-              <a:tr h="0">
+              <a:tr h="454401">
                 <a:tc>
                   <a:txBody>
                     <a:bodyPr/>
@@ -20410,7 +20410,7 @@
                   </a:ext>
                 </a:extLst>
               </a:tr>
-              <a:tr h="0">
+              <a:tr h="454401">
                 <a:tc>
                   <a:txBody>
                     <a:bodyPr/>
@@ -21229,7 +21229,7 @@
           </a:prstGeom>
           <a:extLst>
             <a:ext uri="{C572A759-6A51-4108-AA02-DFA0A04FC94B}">
-              <ma14:wrappingTextBoxFlag xmlns="" xmlns:ma14="http://schemas.microsoft.com/office/mac/drawingml/2011/main" val="0"/>
+              <ma14:wrappingTextBoxFlag xmlns:ma14="http://schemas.microsoft.com/office/mac/drawingml/2011/main" xmlns="" val="0"/>
             </a:ext>
           </a:extLst>
         </p:spPr>
@@ -22042,7 +22042,7 @@
           </a:prstGeom>
           <a:extLst>
             <a:ext uri="{C572A759-6A51-4108-AA02-DFA0A04FC94B}">
-              <ma14:wrappingTextBoxFlag xmlns="" xmlns:ma14="http://schemas.microsoft.com/office/mac/drawingml/2011/main" val="0"/>
+              <ma14:wrappingTextBoxFlag xmlns:ma14="http://schemas.microsoft.com/office/mac/drawingml/2011/main" xmlns="" val="0"/>
             </a:ext>
           </a:extLst>
         </p:spPr>
@@ -23236,7 +23236,7 @@
           </a:prstGeom>
           <a:extLst>
             <a:ext uri="{C572A759-6A51-4108-AA02-DFA0A04FC94B}">
-              <ma14:wrappingTextBoxFlag xmlns="" xmlns:ma14="http://schemas.microsoft.com/office/mac/drawingml/2011/main" val="0"/>
+              <ma14:wrappingTextBoxFlag xmlns:ma14="http://schemas.microsoft.com/office/mac/drawingml/2011/main" xmlns="" val="0"/>
             </a:ext>
           </a:extLst>
         </p:spPr>
@@ -23375,14 +23375,14 @@
           <p:nvPr>
             <p:extLst>
               <p:ext uri="{D42A27DB-BD31-4B8C-83A1-F6EECF244321}">
-                <p14:modId xmlns:p14="http://schemas.microsoft.com/office/powerpoint/2010/main" val="1579011935"/>
+                <p14:modId xmlns:p14="http://schemas.microsoft.com/office/powerpoint/2010/main" val="1649755256"/>
               </p:ext>
             </p:extLst>
           </p:nvPr>
         </p:nvGraphicFramePr>
         <p:xfrm>
-          <a:off x="548640" y="1508760"/>
-          <a:ext cx="6766560" cy="2098040"/>
+          <a:off x="548640" y="1508759"/>
+          <a:ext cx="6766560" cy="2743202"/>
         </p:xfrm>
         <a:graphic>
           <a:graphicData uri="http://schemas.openxmlformats.org/drawingml/2006/table">
@@ -23404,7 +23404,7 @@
                   </a:extLst>
                 </a:gridCol>
               </a:tblGrid>
-              <a:tr h="0">
+              <a:tr h="391886">
                 <a:tc>
                   <a:txBody>
                     <a:bodyPr/>
@@ -23533,7 +23533,7 @@
                   </a:ext>
                 </a:extLst>
               </a:tr>
-              <a:tr h="0">
+              <a:tr h="391886">
                 <a:tc>
                   <a:txBody>
                     <a:bodyPr/>
@@ -23662,7 +23662,7 @@
                   </a:ext>
                 </a:extLst>
               </a:tr>
-              <a:tr h="0">
+              <a:tr h="391886">
                 <a:tc>
                   <a:txBody>
                     <a:bodyPr/>
@@ -23791,7 +23791,7 @@
                   </a:ext>
                 </a:extLst>
               </a:tr>
-              <a:tr h="0">
+              <a:tr h="391886">
                 <a:tc>
                   <a:txBody>
                     <a:bodyPr/>
@@ -23920,7 +23920,7 @@
                   </a:ext>
                 </a:extLst>
               </a:tr>
-              <a:tr h="0">
+              <a:tr h="391886">
                 <a:tc>
                   <a:txBody>
                     <a:bodyPr/>
@@ -24049,7 +24049,7 @@
                   </a:ext>
                 </a:extLst>
               </a:tr>
-              <a:tr h="0">
+              <a:tr h="391886">
                 <a:tc>
                   <a:txBody>
                     <a:bodyPr/>
@@ -24178,7 +24178,7 @@
                   </a:ext>
                 </a:extLst>
               </a:tr>
-              <a:tr h="0">
+              <a:tr h="391886">
                 <a:tc>
                   <a:txBody>
                     <a:bodyPr/>
@@ -24567,7 +24567,7 @@
           </a:prstGeom>
           <a:extLst>
             <a:ext uri="{C572A759-6A51-4108-AA02-DFA0A04FC94B}">
-              <ma14:wrappingTextBoxFlag xmlns="" xmlns:ma14="http://schemas.microsoft.com/office/mac/drawingml/2011/main" val="0"/>
+              <ma14:wrappingTextBoxFlag xmlns:ma14="http://schemas.microsoft.com/office/mac/drawingml/2011/main" xmlns="" val="0"/>
             </a:ext>
           </a:extLst>
         </p:spPr>
@@ -24691,7 +24691,7 @@
                   <a:schemeClr val="bg1"/>
                 </a:solidFill>
               </a:rPr>
-              <a:t>CI/CD — GitHub Actions</a:t>
+              <a:t>CI — GitHub Actions</a:t>
             </a:r>
             <a:endParaRPr lang="en-US" sz="3200" dirty="0"/>
           </a:p>
@@ -25322,7 +25322,7 @@
           </a:prstGeom>
           <a:extLst>
             <a:ext uri="{C572A759-6A51-4108-AA02-DFA0A04FC94B}">
-              <ma14:wrappingTextBoxFlag xmlns="" xmlns:ma14="http://schemas.microsoft.com/office/mac/drawingml/2011/main" val="0"/>
+              <ma14:wrappingTextBoxFlag xmlns:ma14="http://schemas.microsoft.com/office/mac/drawingml/2011/main" xmlns="" val="0"/>
             </a:ext>
           </a:extLst>
         </p:spPr>
@@ -25548,7 +25548,7 @@
         <p:spPr>
           <a:xfrm>
             <a:off x="548640" y="868680"/>
-            <a:ext cx="11064240" cy="685800"/>
+            <a:ext cx="11064240" cy="461665"/>
           </a:xfrm>
           <a:prstGeom prst="rect">
             <a:avLst/>
@@ -25567,14 +25567,56 @@
               </a:lnSpc>
             </a:pPr>
             <a:r>
-              <a:rPr sz="3000" b="1" i="0">
+              <a:rPr sz="3000" b="1" i="0" dirty="0" err="1">
                 <a:solidFill>
                   <a:srgbClr val="FFFFFF"/>
                 </a:solidFill>
                 <a:latin typeface="Calibri"/>
               </a:rPr>
-              <a:t>Метрики качества</a:t>
-            </a:r>
+              <a:t>Метрики</a:t>
+            </a:r>
+            <a:r>
+              <a:rPr sz="3000" b="1" i="0" dirty="0">
+                <a:solidFill>
+                  <a:srgbClr val="FFFFFF"/>
+                </a:solidFill>
+                <a:latin typeface="Calibri"/>
+              </a:rPr>
+              <a:t> </a:t>
+            </a:r>
+            <a:r>
+              <a:rPr sz="3000" b="1" i="0" dirty="0" err="1">
+                <a:solidFill>
+                  <a:srgbClr val="FFFFFF"/>
+                </a:solidFill>
+                <a:latin typeface="Calibri"/>
+              </a:rPr>
+              <a:t>качества</a:t>
+            </a:r>
+            <a:r>
+              <a:rPr lang="en-US" sz="3000" b="1" i="0" dirty="0">
+                <a:solidFill>
+                  <a:srgbClr val="FFFFFF"/>
+                </a:solidFill>
+                <a:latin typeface="Calibri"/>
+              </a:rPr>
+              <a:t> </a:t>
+            </a:r>
+            <a:r>
+              <a:rPr lang="ru-RU" sz="3000" b="1" i="0" dirty="0">
+                <a:solidFill>
+                  <a:srgbClr val="FFFFFF"/>
+                </a:solidFill>
+                <a:latin typeface="Calibri"/>
+              </a:rPr>
+              <a:t>на бенчмарке</a:t>
+            </a:r>
+            <a:endParaRPr sz="3000" b="1" i="0" dirty="0">
+              <a:solidFill>
+                <a:srgbClr val="FFFFFF"/>
+              </a:solidFill>
+              <a:latin typeface="Calibri"/>
+            </a:endParaRPr>
           </a:p>
         </p:txBody>
       </p:sp>
@@ -25714,7 +25756,7 @@
         <p:spPr>
           <a:xfrm>
             <a:off x="777240" y="1947672"/>
-            <a:ext cx="2011680" cy="640080"/>
+            <a:ext cx="2011680" cy="523220"/>
           </a:xfrm>
           <a:prstGeom prst="rect">
             <a:avLst/>
@@ -25733,13 +25775,22 @@
               </a:lnSpc>
             </a:pPr>
             <a:r>
-              <a:rPr sz="3400" b="1" i="0">
+              <a:rPr lang="en-US" sz="3400" b="1" dirty="0">
                 <a:solidFill>
                   <a:srgbClr val="FF5A36"/>
                 </a:solidFill>
                 <a:latin typeface="Calibri"/>
               </a:rPr>
-              <a:t>83,3%</a:t>
+              <a:t>100</a:t>
+            </a:r>
+            <a:r>
+              <a:rPr sz="3400" b="1" i="0" dirty="0">
+                <a:solidFill>
+                  <a:srgbClr val="FF5A36"/>
+                </a:solidFill>
+                <a:latin typeface="Calibri"/>
+              </a:rPr>
+              <a:t>%</a:t>
             </a:r>
           </a:p>
         </p:txBody>
@@ -25792,7 +25843,7 @@
         <p:spPr>
           <a:xfrm>
             <a:off x="2834640" y="2350008"/>
-            <a:ext cx="2926080" cy="731520"/>
+            <a:ext cx="2926080" cy="379591"/>
           </a:xfrm>
           <a:prstGeom prst="rect">
             <a:avLst/>
@@ -25811,13 +25862,157 @@
               </a:lnSpc>
             </a:pPr>
             <a:r>
-              <a:rPr sz="1150" b="0" i="0">
+              <a:rPr sz="1150" b="0" i="0" dirty="0">
                 <a:solidFill>
                   <a:srgbClr val="8A97A6"/>
                 </a:solidFill>
                 <a:latin typeface="Calibri"/>
               </a:rPr>
-              <a:t>5 из 6 запросов прошли проверку по числу (допуск 1%)</a:t>
+              <a:t>5 </a:t>
+            </a:r>
+            <a:r>
+              <a:rPr sz="1150" b="0" i="0" dirty="0" err="1">
+                <a:solidFill>
+                  <a:srgbClr val="8A97A6"/>
+                </a:solidFill>
+                <a:latin typeface="Calibri"/>
+              </a:rPr>
+              <a:t>из</a:t>
+            </a:r>
+            <a:r>
+              <a:rPr sz="1150" b="0" i="0" dirty="0">
+                <a:solidFill>
+                  <a:srgbClr val="8A97A6"/>
+                </a:solidFill>
+                <a:latin typeface="Calibri"/>
+              </a:rPr>
+              <a:t> </a:t>
+            </a:r>
+            <a:r>
+              <a:rPr lang="en-US" sz="1150" b="0" i="0" dirty="0">
+                <a:solidFill>
+                  <a:srgbClr val="8A97A6"/>
+                </a:solidFill>
+                <a:latin typeface="Calibri"/>
+              </a:rPr>
+              <a:t>5</a:t>
+            </a:r>
+            <a:r>
+              <a:rPr sz="1150" b="0" i="0" dirty="0">
+                <a:solidFill>
+                  <a:srgbClr val="8A97A6"/>
+                </a:solidFill>
+                <a:latin typeface="Calibri"/>
+              </a:rPr>
+              <a:t> </a:t>
+            </a:r>
+            <a:r>
+              <a:rPr sz="1150" b="0" i="0" dirty="0" err="1">
+                <a:solidFill>
+                  <a:srgbClr val="8A97A6"/>
+                </a:solidFill>
+                <a:latin typeface="Calibri"/>
+              </a:rPr>
+              <a:t>запросов</a:t>
+            </a:r>
+            <a:r>
+              <a:rPr sz="1150" b="0" i="0" dirty="0">
+                <a:solidFill>
+                  <a:srgbClr val="8A97A6"/>
+                </a:solidFill>
+                <a:latin typeface="Calibri"/>
+              </a:rPr>
+              <a:t> </a:t>
+            </a:r>
+            <a:r>
+              <a:rPr sz="1150" b="0" i="0" dirty="0" err="1">
+                <a:solidFill>
+                  <a:srgbClr val="8A97A6"/>
+                </a:solidFill>
+                <a:latin typeface="Calibri"/>
+              </a:rPr>
+              <a:t>прошли</a:t>
+            </a:r>
+            <a:r>
+              <a:rPr sz="1150" b="0" i="0" dirty="0">
+                <a:solidFill>
+                  <a:srgbClr val="8A97A6"/>
+                </a:solidFill>
+                <a:latin typeface="Calibri"/>
+              </a:rPr>
+              <a:t> </a:t>
+            </a:r>
+            <a:r>
+              <a:rPr sz="1150" b="0" i="0" dirty="0" err="1">
+                <a:solidFill>
+                  <a:srgbClr val="8A97A6"/>
+                </a:solidFill>
+                <a:latin typeface="Calibri"/>
+              </a:rPr>
+              <a:t>проверку</a:t>
+            </a:r>
+            <a:r>
+              <a:rPr sz="1150" b="0" i="0" dirty="0">
+                <a:solidFill>
+                  <a:srgbClr val="8A97A6"/>
+                </a:solidFill>
+                <a:latin typeface="Calibri"/>
+              </a:rPr>
+              <a:t> </a:t>
+            </a:r>
+            <a:r>
+              <a:rPr sz="1150" b="0" i="0" dirty="0" err="1">
+                <a:solidFill>
+                  <a:srgbClr val="8A97A6"/>
+                </a:solidFill>
+                <a:latin typeface="Calibri"/>
+              </a:rPr>
+              <a:t>по</a:t>
+            </a:r>
+            <a:r>
+              <a:rPr sz="1150" b="0" i="0" dirty="0">
+                <a:solidFill>
+                  <a:srgbClr val="8A97A6"/>
+                </a:solidFill>
+                <a:latin typeface="Calibri"/>
+              </a:rPr>
+              <a:t> </a:t>
+            </a:r>
+            <a:r>
+              <a:rPr sz="1150" b="0" i="0" dirty="0" err="1">
+                <a:solidFill>
+                  <a:srgbClr val="8A97A6"/>
+                </a:solidFill>
+                <a:latin typeface="Calibri"/>
+              </a:rPr>
+              <a:t>числу</a:t>
+            </a:r>
+            <a:r>
+              <a:rPr sz="1150" b="0" i="0" dirty="0">
+                <a:solidFill>
+                  <a:srgbClr val="8A97A6"/>
+                </a:solidFill>
+                <a:latin typeface="Calibri"/>
+              </a:rPr>
+              <a:t> (</a:t>
+            </a:r>
+            <a:r>
+              <a:rPr sz="1150" b="0" i="0" dirty="0" err="1">
+                <a:solidFill>
+                  <a:srgbClr val="8A97A6"/>
+                </a:solidFill>
+                <a:latin typeface="Calibri"/>
+              </a:rPr>
+              <a:t>допуск</a:t>
+            </a:r>
+            <a:r>
+              <a:rPr sz="1150" b="0" i="0" dirty="0">
+                <a:solidFill>
+                  <a:srgbClr val="8A97A6"/>
+                </a:solidFill>
+                <a:latin typeface="Calibri"/>
+              </a:rPr>
+              <a:t> 1%)</a:t>
             </a:r>
           </a:p>
         </p:txBody>
@@ -27952,7 +28147,7 @@
           </a:prstGeom>
           <a:extLst>
             <a:ext uri="{C572A759-6A51-4108-AA02-DFA0A04FC94B}">
-              <ma14:wrappingTextBoxFlag xmlns="" xmlns:ma14="http://schemas.microsoft.com/office/mac/drawingml/2011/main" val="0"/>
+              <ma14:wrappingTextBoxFlag xmlns:ma14="http://schemas.microsoft.com/office/mac/drawingml/2011/main" xmlns="" val="0"/>
             </a:ext>
           </a:extLst>
         </p:spPr>
@@ -32273,7 +32468,7 @@
           </a:prstGeom>
           <a:extLst>
             <a:ext uri="{C572A759-6A51-4108-AA02-DFA0A04FC94B}">
-              <ma14:wrappingTextBoxFlag xmlns="" xmlns:ma14="http://schemas.microsoft.com/office/mac/drawingml/2011/main" val="0"/>
+              <ma14:wrappingTextBoxFlag xmlns:ma14="http://schemas.microsoft.com/office/mac/drawingml/2011/main" xmlns="" val="0"/>
             </a:ext>
           </a:extLst>
         </p:spPr>
@@ -32891,7 +33086,7 @@
           </a:prstGeom>
           <a:extLst>
             <a:ext uri="{C572A759-6A51-4108-AA02-DFA0A04FC94B}">
-              <ma14:wrappingTextBoxFlag xmlns="" xmlns:ma14="http://schemas.microsoft.com/office/mac/drawingml/2011/main" val="0"/>
+              <ma14:wrappingTextBoxFlag xmlns:ma14="http://schemas.microsoft.com/office/mac/drawingml/2011/main" xmlns="" val="0"/>
             </a:ext>
           </a:extLst>
         </p:spPr>
@@ -34263,7 +34458,7 @@
           </a:prstGeom>
           <a:extLst>
             <a:ext uri="{C572A759-6A51-4108-AA02-DFA0A04FC94B}">
-              <ma14:wrappingTextBoxFlag xmlns="" xmlns:ma14="http://schemas.microsoft.com/office/mac/drawingml/2011/main" val="0"/>
+              <ma14:wrappingTextBoxFlag xmlns:ma14="http://schemas.microsoft.com/office/mac/drawingml/2011/main" xmlns="" val="0"/>
             </a:ext>
           </a:extLst>
         </p:spPr>
@@ -34831,7 +35026,7 @@
           </a:prstGeom>
           <a:extLst>
             <a:ext uri="{C572A759-6A51-4108-AA02-DFA0A04FC94B}">
-              <ma14:wrappingTextBoxFlag xmlns="" xmlns:ma14="http://schemas.microsoft.com/office/mac/drawingml/2011/main" val="0"/>
+              <ma14:wrappingTextBoxFlag xmlns:ma14="http://schemas.microsoft.com/office/mac/drawingml/2011/main" xmlns="" val="0"/>
             </a:ext>
           </a:extLst>
         </p:spPr>
@@ -34906,14 +35101,14 @@
               <a:buNone/>
             </a:pPr>
             <a:r>
-              <a:rPr lang="en-US" sz="1600" b="1" dirty="0">
+              <a:rPr lang="en-US" sz="4000" b="1" dirty="0">
                 <a:solidFill>
                   <a:schemeClr val="accent1"/>
                 </a:solidFill>
               </a:rPr>
               <a:t>СПАСИБО ЗА ВНИМАНИЕ</a:t>
             </a:r>
-            <a:endParaRPr lang="en-US" sz="1600" dirty="0"/>
+            <a:endParaRPr lang="en-US" sz="4000" dirty="0"/>
           </a:p>
         </p:txBody>
       </p:sp>
@@ -34941,14 +35136,6 @@
             <a:pPr marL="0" indent="0">
               <a:buNone/>
             </a:pPr>
-            <a:r>
-              <a:rPr lang="en-US" sz="6000" b="1" dirty="0">
-                <a:solidFill>
-                  <a:schemeClr val="bg1"/>
-                </a:solidFill>
-              </a:rPr>
-              <a:t>Вопросы?</a:t>
-            </a:r>
             <a:endParaRPr lang="en-US" sz="6000" dirty="0"/>
           </a:p>
         </p:txBody>
@@ -34983,8 +35170,26 @@
                   <a:schemeClr val="bg2"/>
                 </a:solidFill>
               </a:rPr>
-              <a:t>EVRAZ Agent — AI-агент для интеллектуальной работы с Excel-файлами</a:t>
-            </a:r>
+              <a:t>EVRAZ Agent — AI-агент для интеллектуальной работы с Excel-</a:t>
+            </a:r>
+            <a:r>
+              <a:rPr lang="en-US" sz="2000" dirty="0" err="1">
+                <a:solidFill>
+                  <a:schemeClr val="bg2"/>
+                </a:solidFill>
+              </a:rPr>
+              <a:t>файлами</a:t>
+            </a:r>
+            <a:endParaRPr lang="ru-RU" sz="2000" dirty="0">
+              <a:solidFill>
+                <a:schemeClr val="bg2"/>
+              </a:solidFill>
+            </a:endParaRPr>
+          </a:p>
+          <a:p>
+            <a:pPr marL="0" indent="0">
+              <a:buNone/>
+            </a:pPr>
             <a:endParaRPr lang="en-US" sz="2000" dirty="0"/>
           </a:p>
         </p:txBody>
@@ -35950,7 +36155,7 @@
           </a:prstGeom>
           <a:extLst>
             <a:ext uri="{C572A759-6A51-4108-AA02-DFA0A04FC94B}">
-              <ma14:wrappingTextBoxFlag xmlns="" xmlns:ma14="http://schemas.microsoft.com/office/mac/drawingml/2011/main" val="0"/>
+              <ma14:wrappingTextBoxFlag xmlns:ma14="http://schemas.microsoft.com/office/mac/drawingml/2011/main" xmlns="" val="0"/>
             </a:ext>
           </a:extLst>
         </p:spPr>
@@ -36969,7 +37174,7 @@
                   <a:schemeClr val="accent1"/>
                 </a:solidFill>
               </a:rPr>
-              <a:t>≥ 85%</a:t>
+              <a:t>≥ 80%</a:t>
             </a:r>
             <a:endParaRPr lang="en-US" sz="5400" dirty="0"/>
           </a:p>
@@ -37137,7 +37342,7 @@
           </a:prstGeom>
           <a:extLst>
             <a:ext uri="{C572A759-6A51-4108-AA02-DFA0A04FC94B}">
-              <ma14:wrappingTextBoxFlag xmlns="" xmlns:ma14="http://schemas.microsoft.com/office/mac/drawingml/2011/main" val="0"/>
+              <ma14:wrappingTextBoxFlag xmlns:ma14="http://schemas.microsoft.com/office/mac/drawingml/2011/main" xmlns="" val="0"/>
             </a:ext>
           </a:extLst>
         </p:spPr>
@@ -38791,7 +38996,7 @@
           </a:prstGeom>
           <a:extLst>
             <a:ext uri="{C572A759-6A51-4108-AA02-DFA0A04FC94B}">
-              <ma14:wrappingTextBoxFlag xmlns="" xmlns:ma14="http://schemas.microsoft.com/office/mac/drawingml/2011/main" val="0"/>
+              <ma14:wrappingTextBoxFlag xmlns:ma14="http://schemas.microsoft.com/office/mac/drawingml/2011/main" xmlns="" val="0"/>
             </a:ext>
           </a:extLst>
         </p:spPr>
@@ -40093,7 +40298,7 @@
           </a:prstGeom>
           <a:extLst>
             <a:ext uri="{C572A759-6A51-4108-AA02-DFA0A04FC94B}">
-              <ma14:wrappingTextBoxFlag xmlns="" xmlns:ma14="http://schemas.microsoft.com/office/mac/drawingml/2011/main" val="0"/>
+              <ma14:wrappingTextBoxFlag xmlns:ma14="http://schemas.microsoft.com/office/mac/drawingml/2011/main" xmlns="" val="0"/>
             </a:ext>
           </a:extLst>
         </p:spPr>
@@ -40739,7 +40944,7 @@
           </a:prstGeom>
           <a:extLst>
             <a:ext uri="{C572A759-6A51-4108-AA02-DFA0A04FC94B}">
-              <ma14:wrappingTextBoxFlag xmlns="" xmlns:ma14="http://schemas.microsoft.com/office/mac/drawingml/2011/main" val="0"/>
+              <ma14:wrappingTextBoxFlag xmlns:ma14="http://schemas.microsoft.com/office/mac/drawingml/2011/main" xmlns="" val="0"/>
             </a:ext>
           </a:extLst>
         </p:spPr>
@@ -41489,7 +41694,7 @@
           </a:prstGeom>
           <a:extLst>
             <a:ext uri="{C572A759-6A51-4108-AA02-DFA0A04FC94B}">
-              <ma14:wrappingTextBoxFlag xmlns="" xmlns:ma14="http://schemas.microsoft.com/office/mac/drawingml/2011/main" val="0"/>
+              <ma14:wrappingTextBoxFlag xmlns:ma14="http://schemas.microsoft.com/office/mac/drawingml/2011/main" xmlns="" val="0"/>
             </a:ext>
           </a:extLst>
         </p:spPr>

</xml_diff>